<commit_message>
Add new & Update ppt
</commit_message>
<xml_diff>
--- a/中越詩歌/天使報信_Kìa Thiên Binh Cùng Nhau Trổi Hát.pptx
+++ b/中越詩歌/天使報信_Kìa Thiên Binh Cùng Nhau Trổi Hát.pptx
@@ -190,7 +190,7 @@
           <a:lstStyle/>
           <a:p>
             <a:r>
-              <a:rPr lang="en-US" altLang="zh-TW" smtClean="0"/>
+              <a:rPr lang="en-US" altLang="zh-TW"/>
               <a:t>Click to edit Master title style</a:t>
             </a:r>
             <a:endParaRPr lang="zh-TW" altLang="en-US"/>
@@ -309,7 +309,7 @@
           </a:lstStyle>
           <a:p>
             <a:r>
-              <a:rPr lang="en-US" altLang="zh-TW" smtClean="0"/>
+              <a:rPr lang="en-US" altLang="zh-TW"/>
               <a:t>Click to edit Master subtitle style</a:t>
             </a:r>
             <a:endParaRPr lang="zh-TW" altLang="en-US"/>
@@ -333,7 +333,7 @@
           <a:p>
             <a:fld id="{F98C8AF4-3B58-4868-8ABF-BFB3B1D0CE14}" type="datetimeFigureOut">
               <a:rPr lang="vi-VN" smtClean="0"/>
-              <a:t>24/12/2022</a:t>
+              <a:t>21/12/2024</a:t>
             </a:fld>
             <a:endParaRPr lang="vi-VN"/>
           </a:p>
@@ -427,7 +427,7 @@
           <a:lstStyle/>
           <a:p>
             <a:r>
-              <a:rPr lang="en-US" altLang="zh-TW" smtClean="0"/>
+              <a:rPr lang="en-US" altLang="zh-TW"/>
               <a:t>Click to edit Master title style</a:t>
             </a:r>
             <a:endParaRPr lang="zh-TW" altLang="en-US"/>
@@ -451,35 +451,35 @@
           <a:p>
             <a:pPr lvl="0"/>
             <a:r>
-              <a:rPr lang="en-US" altLang="zh-TW" smtClean="0"/>
+              <a:rPr lang="en-US" altLang="zh-TW"/>
               <a:t>Edit Master text styles</a:t>
             </a:r>
           </a:p>
           <a:p>
             <a:pPr lvl="1"/>
             <a:r>
-              <a:rPr lang="en-US" altLang="zh-TW" smtClean="0"/>
+              <a:rPr lang="en-US" altLang="zh-TW"/>
               <a:t>Second level</a:t>
             </a:r>
           </a:p>
           <a:p>
             <a:pPr lvl="2"/>
             <a:r>
-              <a:rPr lang="en-US" altLang="zh-TW" smtClean="0"/>
+              <a:rPr lang="en-US" altLang="zh-TW"/>
               <a:t>Third level</a:t>
             </a:r>
           </a:p>
           <a:p>
             <a:pPr lvl="3"/>
             <a:r>
-              <a:rPr lang="en-US" altLang="zh-TW" smtClean="0"/>
+              <a:rPr lang="en-US" altLang="zh-TW"/>
               <a:t>Fourth level</a:t>
             </a:r>
           </a:p>
           <a:p>
             <a:pPr lvl="4"/>
             <a:r>
-              <a:rPr lang="en-US" altLang="zh-TW" smtClean="0"/>
+              <a:rPr lang="en-US" altLang="zh-TW"/>
               <a:t>Fifth level</a:t>
             </a:r>
             <a:endParaRPr lang="zh-TW" altLang="en-US"/>
@@ -503,7 +503,7 @@
           <a:p>
             <a:fld id="{F98C8AF4-3B58-4868-8ABF-BFB3B1D0CE14}" type="datetimeFigureOut">
               <a:rPr lang="vi-VN" smtClean="0"/>
-              <a:t>24/12/2022</a:t>
+              <a:t>21/12/2024</a:t>
             </a:fld>
             <a:endParaRPr lang="vi-VN"/>
           </a:p>
@@ -602,7 +602,7 @@
           <a:lstStyle/>
           <a:p>
             <a:r>
-              <a:rPr lang="en-US" altLang="zh-TW" smtClean="0"/>
+              <a:rPr lang="en-US" altLang="zh-TW"/>
               <a:t>Click to edit Master title style</a:t>
             </a:r>
             <a:endParaRPr lang="zh-TW" altLang="en-US"/>
@@ -631,35 +631,35 @@
           <a:p>
             <a:pPr lvl="0"/>
             <a:r>
-              <a:rPr lang="en-US" altLang="zh-TW" smtClean="0"/>
+              <a:rPr lang="en-US" altLang="zh-TW"/>
               <a:t>Edit Master text styles</a:t>
             </a:r>
           </a:p>
           <a:p>
             <a:pPr lvl="1"/>
             <a:r>
-              <a:rPr lang="en-US" altLang="zh-TW" smtClean="0"/>
+              <a:rPr lang="en-US" altLang="zh-TW"/>
               <a:t>Second level</a:t>
             </a:r>
           </a:p>
           <a:p>
             <a:pPr lvl="2"/>
             <a:r>
-              <a:rPr lang="en-US" altLang="zh-TW" smtClean="0"/>
+              <a:rPr lang="en-US" altLang="zh-TW"/>
               <a:t>Third level</a:t>
             </a:r>
           </a:p>
           <a:p>
             <a:pPr lvl="3"/>
             <a:r>
-              <a:rPr lang="en-US" altLang="zh-TW" smtClean="0"/>
+              <a:rPr lang="en-US" altLang="zh-TW"/>
               <a:t>Fourth level</a:t>
             </a:r>
           </a:p>
           <a:p>
             <a:pPr lvl="4"/>
             <a:r>
-              <a:rPr lang="en-US" altLang="zh-TW" smtClean="0"/>
+              <a:rPr lang="en-US" altLang="zh-TW"/>
               <a:t>Fifth level</a:t>
             </a:r>
             <a:endParaRPr lang="zh-TW" altLang="en-US"/>
@@ -683,7 +683,7 @@
           <a:p>
             <a:fld id="{F98C8AF4-3B58-4868-8ABF-BFB3B1D0CE14}" type="datetimeFigureOut">
               <a:rPr lang="vi-VN" smtClean="0"/>
-              <a:t>24/12/2022</a:t>
+              <a:t>21/12/2024</a:t>
             </a:fld>
             <a:endParaRPr lang="vi-VN"/>
           </a:p>
@@ -777,7 +777,7 @@
           <a:lstStyle/>
           <a:p>
             <a:r>
-              <a:rPr lang="en-US" altLang="zh-TW" smtClean="0"/>
+              <a:rPr lang="en-US" altLang="zh-TW"/>
               <a:t>Click to edit Master title style</a:t>
             </a:r>
             <a:endParaRPr lang="zh-TW" altLang="en-US"/>
@@ -801,35 +801,35 @@
           <a:p>
             <a:pPr lvl="0"/>
             <a:r>
-              <a:rPr lang="en-US" altLang="zh-TW" smtClean="0"/>
+              <a:rPr lang="en-US" altLang="zh-TW"/>
               <a:t>Edit Master text styles</a:t>
             </a:r>
           </a:p>
           <a:p>
             <a:pPr lvl="1"/>
             <a:r>
-              <a:rPr lang="en-US" altLang="zh-TW" smtClean="0"/>
+              <a:rPr lang="en-US" altLang="zh-TW"/>
               <a:t>Second level</a:t>
             </a:r>
           </a:p>
           <a:p>
             <a:pPr lvl="2"/>
             <a:r>
-              <a:rPr lang="en-US" altLang="zh-TW" smtClean="0"/>
+              <a:rPr lang="en-US" altLang="zh-TW"/>
               <a:t>Third level</a:t>
             </a:r>
           </a:p>
           <a:p>
             <a:pPr lvl="3"/>
             <a:r>
-              <a:rPr lang="en-US" altLang="zh-TW" smtClean="0"/>
+              <a:rPr lang="en-US" altLang="zh-TW"/>
               <a:t>Fourth level</a:t>
             </a:r>
           </a:p>
           <a:p>
             <a:pPr lvl="4"/>
             <a:r>
-              <a:rPr lang="en-US" altLang="zh-TW" smtClean="0"/>
+              <a:rPr lang="en-US" altLang="zh-TW"/>
               <a:t>Fifth level</a:t>
             </a:r>
             <a:endParaRPr lang="zh-TW" altLang="en-US"/>
@@ -853,7 +853,7 @@
           <a:p>
             <a:fld id="{F98C8AF4-3B58-4868-8ABF-BFB3B1D0CE14}" type="datetimeFigureOut">
               <a:rPr lang="vi-VN" smtClean="0"/>
-              <a:t>24/12/2022</a:t>
+              <a:t>21/12/2024</a:t>
             </a:fld>
             <a:endParaRPr lang="vi-VN"/>
           </a:p>
@@ -956,7 +956,7 @@
           </a:lstStyle>
           <a:p>
             <a:r>
-              <a:rPr lang="en-US" altLang="zh-TW" smtClean="0"/>
+              <a:rPr lang="en-US" altLang="zh-TW"/>
               <a:t>Click to edit Master title style</a:t>
             </a:r>
             <a:endParaRPr lang="zh-TW" altLang="en-US"/>
@@ -1076,7 +1076,7 @@
           <a:p>
             <a:pPr lvl="0"/>
             <a:r>
-              <a:rPr lang="en-US" altLang="zh-TW" smtClean="0"/>
+              <a:rPr lang="en-US" altLang="zh-TW"/>
               <a:t>Edit Master text styles</a:t>
             </a:r>
           </a:p>
@@ -1099,7 +1099,7 @@
           <a:p>
             <a:fld id="{F98C8AF4-3B58-4868-8ABF-BFB3B1D0CE14}" type="datetimeFigureOut">
               <a:rPr lang="vi-VN" smtClean="0"/>
-              <a:t>24/12/2022</a:t>
+              <a:t>21/12/2024</a:t>
             </a:fld>
             <a:endParaRPr lang="vi-VN"/>
           </a:p>
@@ -1193,7 +1193,7 @@
           <a:lstStyle/>
           <a:p>
             <a:r>
-              <a:rPr lang="en-US" altLang="zh-TW" smtClean="0"/>
+              <a:rPr lang="en-US" altLang="zh-TW"/>
               <a:t>Click to edit Master title style</a:t>
             </a:r>
             <a:endParaRPr lang="zh-TW" altLang="en-US"/>
@@ -1250,35 +1250,35 @@
           <a:p>
             <a:pPr lvl="0"/>
             <a:r>
-              <a:rPr lang="en-US" altLang="zh-TW" smtClean="0"/>
+              <a:rPr lang="en-US" altLang="zh-TW"/>
               <a:t>Edit Master text styles</a:t>
             </a:r>
           </a:p>
           <a:p>
             <a:pPr lvl="1"/>
             <a:r>
-              <a:rPr lang="en-US" altLang="zh-TW" smtClean="0"/>
+              <a:rPr lang="en-US" altLang="zh-TW"/>
               <a:t>Second level</a:t>
             </a:r>
           </a:p>
           <a:p>
             <a:pPr lvl="2"/>
             <a:r>
-              <a:rPr lang="en-US" altLang="zh-TW" smtClean="0"/>
+              <a:rPr lang="en-US" altLang="zh-TW"/>
               <a:t>Third level</a:t>
             </a:r>
           </a:p>
           <a:p>
             <a:pPr lvl="3"/>
             <a:r>
-              <a:rPr lang="en-US" altLang="zh-TW" smtClean="0"/>
+              <a:rPr lang="en-US" altLang="zh-TW"/>
               <a:t>Fourth level</a:t>
             </a:r>
           </a:p>
           <a:p>
             <a:pPr lvl="4"/>
             <a:r>
-              <a:rPr lang="en-US" altLang="zh-TW" smtClean="0"/>
+              <a:rPr lang="en-US" altLang="zh-TW"/>
               <a:t>Fifth level</a:t>
             </a:r>
             <a:endParaRPr lang="zh-TW" altLang="en-US"/>
@@ -1335,35 +1335,35 @@
           <a:p>
             <a:pPr lvl="0"/>
             <a:r>
-              <a:rPr lang="en-US" altLang="zh-TW" smtClean="0"/>
+              <a:rPr lang="en-US" altLang="zh-TW"/>
               <a:t>Edit Master text styles</a:t>
             </a:r>
           </a:p>
           <a:p>
             <a:pPr lvl="1"/>
             <a:r>
-              <a:rPr lang="en-US" altLang="zh-TW" smtClean="0"/>
+              <a:rPr lang="en-US" altLang="zh-TW"/>
               <a:t>Second level</a:t>
             </a:r>
           </a:p>
           <a:p>
             <a:pPr lvl="2"/>
             <a:r>
-              <a:rPr lang="en-US" altLang="zh-TW" smtClean="0"/>
+              <a:rPr lang="en-US" altLang="zh-TW"/>
               <a:t>Third level</a:t>
             </a:r>
           </a:p>
           <a:p>
             <a:pPr lvl="3"/>
             <a:r>
-              <a:rPr lang="en-US" altLang="zh-TW" smtClean="0"/>
+              <a:rPr lang="en-US" altLang="zh-TW"/>
               <a:t>Fourth level</a:t>
             </a:r>
           </a:p>
           <a:p>
             <a:pPr lvl="4"/>
             <a:r>
-              <a:rPr lang="en-US" altLang="zh-TW" smtClean="0"/>
+              <a:rPr lang="en-US" altLang="zh-TW"/>
               <a:t>Fifth level</a:t>
             </a:r>
             <a:endParaRPr lang="zh-TW" altLang="en-US"/>
@@ -1387,7 +1387,7 @@
           <a:p>
             <a:fld id="{F98C8AF4-3B58-4868-8ABF-BFB3B1D0CE14}" type="datetimeFigureOut">
               <a:rPr lang="vi-VN" smtClean="0"/>
-              <a:t>24/12/2022</a:t>
+              <a:t>21/12/2024</a:t>
             </a:fld>
             <a:endParaRPr lang="vi-VN"/>
           </a:p>
@@ -1485,7 +1485,7 @@
           </a:lstStyle>
           <a:p>
             <a:r>
-              <a:rPr lang="en-US" altLang="zh-TW" smtClean="0"/>
+              <a:rPr lang="en-US" altLang="zh-TW"/>
               <a:t>Click to edit Master title style</a:t>
             </a:r>
             <a:endParaRPr lang="zh-TW" altLang="en-US"/>
@@ -1551,7 +1551,7 @@
           <a:p>
             <a:pPr lvl="0"/>
             <a:r>
-              <a:rPr lang="en-US" altLang="zh-TW" smtClean="0"/>
+              <a:rPr lang="en-US" altLang="zh-TW"/>
               <a:t>Edit Master text styles</a:t>
             </a:r>
           </a:p>
@@ -1607,35 +1607,35 @@
           <a:p>
             <a:pPr lvl="0"/>
             <a:r>
-              <a:rPr lang="en-US" altLang="zh-TW" smtClean="0"/>
+              <a:rPr lang="en-US" altLang="zh-TW"/>
               <a:t>Edit Master text styles</a:t>
             </a:r>
           </a:p>
           <a:p>
             <a:pPr lvl="1"/>
             <a:r>
-              <a:rPr lang="en-US" altLang="zh-TW" smtClean="0"/>
+              <a:rPr lang="en-US" altLang="zh-TW"/>
               <a:t>Second level</a:t>
             </a:r>
           </a:p>
           <a:p>
             <a:pPr lvl="2"/>
             <a:r>
-              <a:rPr lang="en-US" altLang="zh-TW" smtClean="0"/>
+              <a:rPr lang="en-US" altLang="zh-TW"/>
               <a:t>Third level</a:t>
             </a:r>
           </a:p>
           <a:p>
             <a:pPr lvl="3"/>
             <a:r>
-              <a:rPr lang="en-US" altLang="zh-TW" smtClean="0"/>
+              <a:rPr lang="en-US" altLang="zh-TW"/>
               <a:t>Fourth level</a:t>
             </a:r>
           </a:p>
           <a:p>
             <a:pPr lvl="4"/>
             <a:r>
-              <a:rPr lang="en-US" altLang="zh-TW" smtClean="0"/>
+              <a:rPr lang="en-US" altLang="zh-TW"/>
               <a:t>Fifth level</a:t>
             </a:r>
             <a:endParaRPr lang="zh-TW" altLang="en-US"/>
@@ -1701,7 +1701,7 @@
           <a:p>
             <a:pPr lvl="0"/>
             <a:r>
-              <a:rPr lang="en-US" altLang="zh-TW" smtClean="0"/>
+              <a:rPr lang="en-US" altLang="zh-TW"/>
               <a:t>Edit Master text styles</a:t>
             </a:r>
           </a:p>
@@ -1757,35 +1757,35 @@
           <a:p>
             <a:pPr lvl="0"/>
             <a:r>
-              <a:rPr lang="en-US" altLang="zh-TW" smtClean="0"/>
+              <a:rPr lang="en-US" altLang="zh-TW"/>
               <a:t>Edit Master text styles</a:t>
             </a:r>
           </a:p>
           <a:p>
             <a:pPr lvl="1"/>
             <a:r>
-              <a:rPr lang="en-US" altLang="zh-TW" smtClean="0"/>
+              <a:rPr lang="en-US" altLang="zh-TW"/>
               <a:t>Second level</a:t>
             </a:r>
           </a:p>
           <a:p>
             <a:pPr lvl="2"/>
             <a:r>
-              <a:rPr lang="en-US" altLang="zh-TW" smtClean="0"/>
+              <a:rPr lang="en-US" altLang="zh-TW"/>
               <a:t>Third level</a:t>
             </a:r>
           </a:p>
           <a:p>
             <a:pPr lvl="3"/>
             <a:r>
-              <a:rPr lang="en-US" altLang="zh-TW" smtClean="0"/>
+              <a:rPr lang="en-US" altLang="zh-TW"/>
               <a:t>Fourth level</a:t>
             </a:r>
           </a:p>
           <a:p>
             <a:pPr lvl="4"/>
             <a:r>
-              <a:rPr lang="en-US" altLang="zh-TW" smtClean="0"/>
+              <a:rPr lang="en-US" altLang="zh-TW"/>
               <a:t>Fifth level</a:t>
             </a:r>
             <a:endParaRPr lang="zh-TW" altLang="en-US"/>
@@ -1809,7 +1809,7 @@
           <a:p>
             <a:fld id="{F98C8AF4-3B58-4868-8ABF-BFB3B1D0CE14}" type="datetimeFigureOut">
               <a:rPr lang="vi-VN" smtClean="0"/>
-              <a:t>24/12/2022</a:t>
+              <a:t>21/12/2024</a:t>
             </a:fld>
             <a:endParaRPr lang="vi-VN"/>
           </a:p>
@@ -1903,7 +1903,7 @@
           <a:lstStyle/>
           <a:p>
             <a:r>
-              <a:rPr lang="en-US" altLang="zh-TW" smtClean="0"/>
+              <a:rPr lang="en-US" altLang="zh-TW"/>
               <a:t>Click to edit Master title style</a:t>
             </a:r>
             <a:endParaRPr lang="zh-TW" altLang="en-US"/>
@@ -1927,7 +1927,7 @@
           <a:p>
             <a:fld id="{F98C8AF4-3B58-4868-8ABF-BFB3B1D0CE14}" type="datetimeFigureOut">
               <a:rPr lang="vi-VN" smtClean="0"/>
-              <a:t>24/12/2022</a:t>
+              <a:t>21/12/2024</a:t>
             </a:fld>
             <a:endParaRPr lang="vi-VN"/>
           </a:p>
@@ -2022,7 +2022,7 @@
           <a:p>
             <a:fld id="{F98C8AF4-3B58-4868-8ABF-BFB3B1D0CE14}" type="datetimeFigureOut">
               <a:rPr lang="vi-VN" smtClean="0"/>
-              <a:t>24/12/2022</a:t>
+              <a:t>21/12/2024</a:t>
             </a:fld>
             <a:endParaRPr lang="vi-VN"/>
           </a:p>
@@ -2125,7 +2125,7 @@
           </a:lstStyle>
           <a:p>
             <a:r>
-              <a:rPr lang="en-US" altLang="zh-TW" smtClean="0"/>
+              <a:rPr lang="en-US" altLang="zh-TW"/>
               <a:t>Click to edit Master title style</a:t>
             </a:r>
             <a:endParaRPr lang="zh-TW" altLang="en-US"/>
@@ -2182,35 +2182,35 @@
           <a:p>
             <a:pPr lvl="0"/>
             <a:r>
-              <a:rPr lang="en-US" altLang="zh-TW" smtClean="0"/>
+              <a:rPr lang="en-US" altLang="zh-TW"/>
               <a:t>Edit Master text styles</a:t>
             </a:r>
           </a:p>
           <a:p>
             <a:pPr lvl="1"/>
             <a:r>
-              <a:rPr lang="en-US" altLang="zh-TW" smtClean="0"/>
+              <a:rPr lang="en-US" altLang="zh-TW"/>
               <a:t>Second level</a:t>
             </a:r>
           </a:p>
           <a:p>
             <a:pPr lvl="2"/>
             <a:r>
-              <a:rPr lang="en-US" altLang="zh-TW" smtClean="0"/>
+              <a:rPr lang="en-US" altLang="zh-TW"/>
               <a:t>Third level</a:t>
             </a:r>
           </a:p>
           <a:p>
             <a:pPr lvl="3"/>
             <a:r>
-              <a:rPr lang="en-US" altLang="zh-TW" smtClean="0"/>
+              <a:rPr lang="en-US" altLang="zh-TW"/>
               <a:t>Fourth level</a:t>
             </a:r>
           </a:p>
           <a:p>
             <a:pPr lvl="4"/>
             <a:r>
-              <a:rPr lang="en-US" altLang="zh-TW" smtClean="0"/>
+              <a:rPr lang="en-US" altLang="zh-TW"/>
               <a:t>Fifth level</a:t>
             </a:r>
             <a:endParaRPr lang="zh-TW" altLang="en-US"/>
@@ -2276,7 +2276,7 @@
           <a:p>
             <a:pPr lvl="0"/>
             <a:r>
-              <a:rPr lang="en-US" altLang="zh-TW" smtClean="0"/>
+              <a:rPr lang="en-US" altLang="zh-TW"/>
               <a:t>Edit Master text styles</a:t>
             </a:r>
           </a:p>
@@ -2299,7 +2299,7 @@
           <a:p>
             <a:fld id="{F98C8AF4-3B58-4868-8ABF-BFB3B1D0CE14}" type="datetimeFigureOut">
               <a:rPr lang="vi-VN" smtClean="0"/>
-              <a:t>24/12/2022</a:t>
+              <a:t>21/12/2024</a:t>
             </a:fld>
             <a:endParaRPr lang="vi-VN"/>
           </a:p>
@@ -2402,7 +2402,7 @@
           </a:lstStyle>
           <a:p>
             <a:r>
-              <a:rPr lang="en-US" altLang="zh-TW" smtClean="0"/>
+              <a:rPr lang="en-US" altLang="zh-TW"/>
               <a:t>Click to edit Master title style</a:t>
             </a:r>
             <a:endParaRPr lang="zh-TW" altLang="en-US"/>
@@ -2467,7 +2467,7 @@
           </a:lstStyle>
           <a:p>
             <a:r>
-              <a:rPr lang="en-US" altLang="zh-TW" smtClean="0"/>
+              <a:rPr lang="en-US" altLang="zh-TW"/>
               <a:t>Click icon to add picture</a:t>
             </a:r>
             <a:endParaRPr lang="zh-TW" altLang="en-US"/>
@@ -2533,7 +2533,7 @@
           <a:p>
             <a:pPr lvl="0"/>
             <a:r>
-              <a:rPr lang="en-US" altLang="zh-TW" smtClean="0"/>
+              <a:rPr lang="en-US" altLang="zh-TW"/>
               <a:t>Edit Master text styles</a:t>
             </a:r>
           </a:p>
@@ -2556,7 +2556,7 @@
           <a:p>
             <a:fld id="{F98C8AF4-3B58-4868-8ABF-BFB3B1D0CE14}" type="datetimeFigureOut">
               <a:rPr lang="vi-VN" smtClean="0"/>
-              <a:t>24/12/2022</a:t>
+              <a:t>21/12/2024</a:t>
             </a:fld>
             <a:endParaRPr lang="vi-VN"/>
           </a:p>
@@ -2670,10 +2670,9 @@
           <a:lstStyle/>
           <a:p>
             <a:r>
-              <a:rPr lang="zh-TW" altLang="en-US" smtClean="0"/>
+              <a:rPr lang="zh-TW" altLang="en-US"/>
               <a:t>按一下以編輯母片標題樣式</a:t>
             </a:r>
-            <a:endParaRPr lang="zh-TW" altLang="en-US"/>
           </a:p>
         </p:txBody>
       </p:sp>
@@ -2704,38 +2703,37 @@
           <a:p>
             <a:pPr lvl="0"/>
             <a:r>
-              <a:rPr lang="zh-TW" altLang="en-US" smtClean="0"/>
+              <a:rPr lang="zh-TW" altLang="en-US"/>
               <a:t>按一下以編輯母片文字樣式</a:t>
             </a:r>
           </a:p>
           <a:p>
             <a:pPr lvl="1"/>
             <a:r>
-              <a:rPr lang="zh-TW" altLang="en-US" smtClean="0"/>
+              <a:rPr lang="zh-TW" altLang="en-US"/>
               <a:t>第二層</a:t>
             </a:r>
           </a:p>
           <a:p>
             <a:pPr lvl="2"/>
             <a:r>
-              <a:rPr lang="zh-TW" altLang="en-US" smtClean="0"/>
+              <a:rPr lang="zh-TW" altLang="en-US"/>
               <a:t>第三層</a:t>
             </a:r>
           </a:p>
           <a:p>
             <a:pPr lvl="3"/>
             <a:r>
-              <a:rPr lang="zh-TW" altLang="en-US" smtClean="0"/>
+              <a:rPr lang="zh-TW" altLang="en-US"/>
               <a:t>第四層</a:t>
             </a:r>
           </a:p>
           <a:p>
             <a:pPr lvl="4"/>
             <a:r>
-              <a:rPr lang="zh-TW" altLang="en-US" smtClean="0"/>
+              <a:rPr lang="zh-TW" altLang="en-US"/>
               <a:t>第五層</a:t>
             </a:r>
-            <a:endParaRPr lang="zh-TW" altLang="en-US"/>
           </a:p>
         </p:txBody>
       </p:sp>
@@ -2774,7 +2772,7 @@
           <a:p>
             <a:fld id="{F98C8AF4-3B58-4868-8ABF-BFB3B1D0CE14}" type="datetimeFigureOut">
               <a:rPr lang="vi-VN" smtClean="0"/>
-              <a:t>24/12/2022</a:t>
+              <a:t>21/12/2024</a:t>
             </a:fld>
             <a:endParaRPr lang="vi-VN"/>
           </a:p>
@@ -3172,7 +3170,7 @@
           <a:lstStyle/>
           <a:p>
             <a:r>
-              <a:rPr lang="zh-CN" altLang="en-US" sz="7200" b="1" i="1" dirty="0" smtClean="0">
+              <a:rPr lang="zh-CN" altLang="en-US" sz="7200" b="1" i="1" dirty="0">
                 <a:solidFill>
                   <a:srgbClr val="660033"/>
                 </a:solidFill>
@@ -3186,10 +3184,10 @@
                 <a:latin typeface="微軟正黑體" pitchFamily="34" charset="-120"/>
                 <a:ea typeface="微軟正黑體" pitchFamily="34" charset="-120"/>
               </a:rPr>
-              <a:t>天</a:t>
-            </a:r>
-            <a:r>
-              <a:rPr lang="zh-CN" altLang="en-US" sz="7200" b="1" i="1" dirty="0">
+              <a:t>宣 </a:t>
+            </a:r>
+            <a:r>
+              <a:rPr lang="en-US" altLang="zh-CN" sz="7200" b="1" i="1" dirty="0">
                 <a:solidFill>
                   <a:srgbClr val="660033"/>
                 </a:solidFill>
@@ -3203,7 +3201,24 @@
                 <a:latin typeface="微軟正黑體" pitchFamily="34" charset="-120"/>
                 <a:ea typeface="微軟正黑體" pitchFamily="34" charset="-120"/>
               </a:rPr>
-              <a:t>使報信</a:t>
+              <a:t>283 - </a:t>
+            </a:r>
+            <a:r>
+              <a:rPr lang="zh-CN" altLang="en-US" sz="7200" b="1" i="1" dirty="0">
+                <a:solidFill>
+                  <a:srgbClr val="660033"/>
+                </a:solidFill>
+                <a:effectLst>
+                  <a:outerShdw blurRad="38100" dist="38100" dir="2700000" algn="tl">
+                    <a:srgbClr val="000000">
+                      <a:alpha val="43137"/>
+                    </a:srgbClr>
+                  </a:outerShdw>
+                </a:effectLst>
+                <a:latin typeface="微軟正黑體" pitchFamily="34" charset="-120"/>
+                <a:ea typeface="微軟正黑體" pitchFamily="34" charset="-120"/>
+              </a:rPr>
+              <a:t>天使報信</a:t>
             </a:r>
             <a:endParaRPr lang="zh-TW" altLang="en-US" sz="7200" b="1" i="1" dirty="0">
               <a:solidFill>
@@ -3261,7 +3276,7 @@
           </a:lstStyle>
           <a:p>
             <a:r>
-              <a:rPr lang="vi-VN" sz="4800" b="1" i="1" dirty="0" smtClean="0">
+              <a:rPr lang="en-US" sz="4800" b="1" i="1" dirty="0">
                 <a:solidFill>
                   <a:srgbClr val="000066"/>
                 </a:solidFill>
@@ -3276,7 +3291,7 @@
                 <a:ea typeface="微軟正黑體" pitchFamily="34" charset="-120"/>
                 <a:cs typeface="Calibri" panose="020F0502020204030204" pitchFamily="34" charset="0"/>
               </a:rPr>
-              <a:t>Kìa </a:t>
+              <a:t>TC 53 - </a:t>
             </a:r>
             <a:r>
               <a:rPr lang="vi-VN" sz="4800" b="1" i="1" dirty="0">
@@ -3294,7 +3309,7 @@
                 <a:ea typeface="微軟正黑體" pitchFamily="34" charset="-120"/>
                 <a:cs typeface="Calibri" panose="020F0502020204030204" pitchFamily="34" charset="0"/>
               </a:rPr>
-              <a:t>Thiên Binh Cùng Nhau Trổi Hát</a:t>
+              <a:t>Kìa Thiên Binh Cùng Nhau Trổi Hát</a:t>
             </a:r>
             <a:endParaRPr lang="zh-TW" altLang="en-US" sz="4800" b="1" i="1" dirty="0">
               <a:solidFill>
@@ -4198,23 +4213,7 @@
                   <a:srgbClr val="000066"/>
                 </a:solidFill>
               </a:rPr>
-              <a:t>( </a:t>
-            </a:r>
-            <a:r>
-              <a:rPr lang="en-US" sz="4267" b="1" dirty="0" smtClean="0">
-                <a:solidFill>
-                  <a:srgbClr val="000066"/>
-                </a:solidFill>
-              </a:rPr>
-              <a:t>2 </a:t>
-            </a:r>
-            <a:r>
-              <a:rPr lang="en-US" sz="4267" b="1" dirty="0">
-                <a:solidFill>
-                  <a:srgbClr val="000066"/>
-                </a:solidFill>
-              </a:rPr>
-              <a:t>/ 4 )</a:t>
+              <a:t>( 2 / 4 )</a:t>
             </a:r>
             <a:endParaRPr lang="vi-VN" sz="4267" b="1" dirty="0">
               <a:solidFill>
@@ -4470,29 +4469,7 @@
                 <a:ea typeface="微軟正黑體" pitchFamily="34" charset="-120"/>
                 <a:cs typeface="Calibri" panose="020F0502020204030204" pitchFamily="34" charset="0"/>
               </a:rPr>
-              <a:t>Cứu Chúa Christ </a:t>
-            </a:r>
-            <a:r>
-              <a:rPr lang="vi-VN" sz="4400" b="1" dirty="0" smtClean="0">
-                <a:solidFill>
-                  <a:srgbClr val="000066"/>
-                </a:solidFill>
-                <a:latin typeface="Calibri" panose="020F0502020204030204" pitchFamily="34" charset="0"/>
-                <a:ea typeface="微軟正黑體" pitchFamily="34" charset="-120"/>
-                <a:cs typeface="Calibri" panose="020F0502020204030204" pitchFamily="34" charset="0"/>
-              </a:rPr>
-              <a:t>vững </a:t>
-            </a:r>
-            <a:r>
-              <a:rPr lang="vi-VN" sz="4400" b="1" dirty="0">
-                <a:solidFill>
-                  <a:srgbClr val="000066"/>
-                </a:solidFill>
-                <a:latin typeface="Calibri" panose="020F0502020204030204" pitchFamily="34" charset="0"/>
-                <a:ea typeface="微軟正黑體" pitchFamily="34" charset="-120"/>
-                <a:cs typeface="Calibri" panose="020F0502020204030204" pitchFamily="34" charset="0"/>
-              </a:rPr>
-              <a:t>sanh vô đối</a:t>
+              <a:t>Cứu Chúa Christ vững sanh vô đối</a:t>
             </a:r>
             <a:endParaRPr lang="en-US" sz="4400" b="1" dirty="0">
               <a:solidFill>
@@ -6388,24 +6365,14 @@
               <a:buNone/>
             </a:pPr>
             <a:r>
-              <a:rPr lang="zh-CN" altLang="en-US" sz="6400" b="1" dirty="0" smtClean="0">
+              <a:rPr lang="zh-CN" altLang="en-US" sz="6400" b="1" dirty="0">
                 <a:solidFill>
                   <a:srgbClr val="660033"/>
                 </a:solidFill>
                 <a:latin typeface="微軟正黑體" pitchFamily="34" charset="-120"/>
                 <a:ea typeface="微軟正黑體" pitchFamily="34" charset="-120"/>
               </a:rPr>
-              <a:t>聽</a:t>
-            </a:r>
-            <a:r>
-              <a:rPr lang="zh-CN" altLang="en-US" sz="6400" b="1" dirty="0">
-                <a:solidFill>
-                  <a:srgbClr val="660033"/>
-                </a:solidFill>
-                <a:latin typeface="微軟正黑體" pitchFamily="34" charset="-120"/>
-                <a:ea typeface="微軟正黑體" pitchFamily="34" charset="-120"/>
-              </a:rPr>
-              <a:t>啊天使唱高聲</a:t>
+              <a:t>聽啊天使唱高聲</a:t>
             </a:r>
             <a:endParaRPr lang="en-US" altLang="zh-CN" sz="6400" b="1" dirty="0">
               <a:solidFill>
@@ -6630,23 +6597,7 @@
                   <a:srgbClr val="000066"/>
                 </a:solidFill>
               </a:rPr>
-              <a:t>( </a:t>
-            </a:r>
-            <a:r>
-              <a:rPr lang="en-US" sz="4267" b="1" dirty="0" smtClean="0">
-                <a:solidFill>
-                  <a:srgbClr val="000066"/>
-                </a:solidFill>
-              </a:rPr>
-              <a:t>1 / 4 </a:t>
-            </a:r>
-            <a:r>
-              <a:rPr lang="en-US" sz="4267" b="1" dirty="0">
-                <a:solidFill>
-                  <a:srgbClr val="000066"/>
-                </a:solidFill>
-              </a:rPr>
-              <a:t>)</a:t>
+              <a:t>( 1 / 4 )</a:t>
             </a:r>
             <a:endParaRPr lang="vi-VN" sz="4267" b="1" dirty="0">
               <a:solidFill>
@@ -7540,23 +7491,7 @@
                   <a:srgbClr val="000066"/>
                 </a:solidFill>
               </a:rPr>
-              <a:t>( </a:t>
-            </a:r>
-            <a:r>
-              <a:rPr lang="en-US" sz="4267" b="1" dirty="0" smtClean="0">
-                <a:solidFill>
-                  <a:srgbClr val="000066"/>
-                </a:solidFill>
-              </a:rPr>
-              <a:t>3 </a:t>
-            </a:r>
-            <a:r>
-              <a:rPr lang="en-US" sz="4267" b="1" dirty="0">
-                <a:solidFill>
-                  <a:srgbClr val="000066"/>
-                </a:solidFill>
-              </a:rPr>
-              <a:t>/ 4 )</a:t>
+              <a:t>( 3 / 4 )</a:t>
             </a:r>
             <a:endParaRPr lang="vi-VN" sz="4267" b="1" dirty="0">
               <a:solidFill>
@@ -8110,18 +8045,7 @@
                 <a:ea typeface="微軟正黑體" pitchFamily="34" charset="-120"/>
                 <a:cs typeface="Calibri" panose="020F0502020204030204" pitchFamily="34" charset="0"/>
               </a:rPr>
-              <a:t>Ngài đem theo thần quang vĩnh </a:t>
-            </a:r>
-            <a:r>
-              <a:rPr lang="vi-VN" sz="4400" b="1" dirty="0" smtClean="0">
-                <a:solidFill>
-                  <a:srgbClr val="000066"/>
-                </a:solidFill>
-                <a:latin typeface="Calibri" panose="020F0502020204030204" pitchFamily="34" charset="0"/>
-                <a:ea typeface="微軟正黑體" pitchFamily="34" charset="-120"/>
-                <a:cs typeface="Calibri" panose="020F0502020204030204" pitchFamily="34" charset="0"/>
-              </a:rPr>
-              <a:t>sạch</a:t>
+              <a:t>Ngài đem theo thần quang vĩnh sạch</a:t>
             </a:r>
             <a:endParaRPr lang="en-US" sz="4400" b="1" dirty="0">
               <a:solidFill>
@@ -9355,23 +9279,7 @@
                   <a:srgbClr val="000066"/>
                 </a:solidFill>
               </a:rPr>
-              <a:t>( </a:t>
-            </a:r>
-            <a:r>
-              <a:rPr lang="en-US" sz="4267" b="1" dirty="0" smtClean="0">
-                <a:solidFill>
-                  <a:srgbClr val="000066"/>
-                </a:solidFill>
-              </a:rPr>
-              <a:t>3 / 4 </a:t>
-            </a:r>
-            <a:r>
-              <a:rPr lang="en-US" sz="4267" b="1" dirty="0">
-                <a:solidFill>
-                  <a:srgbClr val="000066"/>
-                </a:solidFill>
-              </a:rPr>
-              <a:t>)</a:t>
+              <a:t>( 3 / 4 )</a:t>
             </a:r>
             <a:endParaRPr lang="vi-VN" sz="4267" b="1" dirty="0">
               <a:solidFill>
@@ -9925,29 +9833,7 @@
                 <a:ea typeface="微軟正黑體" pitchFamily="34" charset="-120"/>
                 <a:cs typeface="Calibri" panose="020F0502020204030204" pitchFamily="34" charset="0"/>
               </a:rPr>
-              <a:t>Chúc Thánh Ðế mới </a:t>
-            </a:r>
-            <a:r>
-              <a:rPr lang="vi-VN" sz="4400" b="1" dirty="0" smtClean="0">
-                <a:solidFill>
-                  <a:srgbClr val="000066"/>
-                </a:solidFill>
-                <a:latin typeface="Calibri" panose="020F0502020204030204" pitchFamily="34" charset="0"/>
-                <a:ea typeface="微軟正黑體" pitchFamily="34" charset="-120"/>
-                <a:cs typeface="Calibri" panose="020F0502020204030204" pitchFamily="34" charset="0"/>
-              </a:rPr>
-              <a:t>sinh </a:t>
-            </a:r>
-            <a:r>
-              <a:rPr lang="vi-VN" sz="4400" b="1" dirty="0">
-                <a:solidFill>
-                  <a:srgbClr val="000066"/>
-                </a:solidFill>
-                <a:latin typeface="Calibri" panose="020F0502020204030204" pitchFamily="34" charset="0"/>
-                <a:ea typeface="微軟正黑體" pitchFamily="34" charset="-120"/>
-                <a:cs typeface="Calibri" panose="020F0502020204030204" pitchFamily="34" charset="0"/>
-              </a:rPr>
-              <a:t>trên đất</a:t>
+              <a:t>Chúc Thánh Ðế mới sinh trên đất</a:t>
             </a:r>
             <a:endParaRPr lang="en-US" sz="4400" b="1" dirty="0">
               <a:solidFill>
@@ -10883,23 +10769,7 @@
                   <a:srgbClr val="000066"/>
                 </a:solidFill>
               </a:rPr>
-              <a:t>( </a:t>
-            </a:r>
-            <a:r>
-              <a:rPr lang="en-US" sz="4267" b="1" dirty="0" smtClean="0">
-                <a:solidFill>
-                  <a:srgbClr val="000066"/>
-                </a:solidFill>
-              </a:rPr>
-              <a:t>4 </a:t>
-            </a:r>
-            <a:r>
-              <a:rPr lang="en-US" sz="4267" b="1" dirty="0">
-                <a:solidFill>
-                  <a:srgbClr val="000066"/>
-                </a:solidFill>
-              </a:rPr>
-              <a:t>/ 4 )</a:t>
+              <a:t>( 4 / 4 )</a:t>
             </a:r>
             <a:endParaRPr lang="vi-VN" sz="4267" b="1" dirty="0">
               <a:solidFill>

</xml_diff>